<commit_message>
docs: finalize public portfolio and presentation package
</commit_message>
<xml_diff>
--- a/presentation/International_Basketball_Analytics_Presentation.pptx
+++ b/presentation/International_Basketball_Analytics_Presentation.pptx
@@ -3196,7 +3196,7 @@
           </a:fontRef>
         </p:style>
         <p:txBody>
-          <a:bodyPr rtlCol="0" anchor="ctr" wrap="square"/>
+          <a:bodyPr rtlCol="0" anchor="ctr"/>
           <a:lstStyle/>
           <a:p>
             <a:pPr algn="ctr">
@@ -3277,7 +3277,7 @@
               </a:defRPr>
             </a:pPr>
             <a:r>
-              <a:t>20 Years of FIBA Competitions (2005–2024): An End-to-End Data, ML &amp; Decision Support System</a:t>
+              <a:t>20 Years of FIBA Competitions (2005-2024): An End-to-End Data, ML &amp; Decision Support System</a:t>
             </a:r>
           </a:p>
         </p:txBody>
@@ -3341,7 +3341,7 @@
               </a:defRPr>
             </a:pPr>
             <a:r>
-              <a:t>Miguel — Basketball Data Analyst &amp; Quantitative Scout</a:t>
+              <a:t>Miguel - Basketball Data Analyst &amp; Quantitative Scout</a:t>
             </a:r>
           </a:p>
         </p:txBody>
@@ -3507,7 +3507,7 @@
               </a:defRPr>
             </a:pPr>
             <a:r>
-              <a:t>Using Bayesian shrinkage (lambda = 0.75) and cluster bootstrap to separate luck from skill.</a:t>
+              <a:t>Bayesian shrinkage (lambda = 0.75) stabilizes noisy tournament shooting toward career priors.</a:t>
             </a:r>
           </a:p>
         </p:txBody>
@@ -3521,7 +3521,7 @@
         <p:spPr>
           <a:xfrm>
             <a:off x="731520" y="1737360"/>
-            <a:ext cx="3383280" cy="4114800"/>
+            <a:ext cx="5120640" cy="4114800"/>
           </a:xfrm>
           <a:prstGeom prst="roundRect">
             <a:avLst/>
@@ -3550,30 +3550,114 @@
           </a:fontRef>
         </p:style>
         <p:txBody>
-          <a:bodyPr rtlCol="0" anchor="ctr" wrap="square" lIns="274320" rIns="274320" tIns="365760"/>
+          <a:bodyPr rtlCol="0" anchor="ctr" wrap="square" lIns="228600" rIns="228600" tIns="228600"/>
           <a:lstStyle/>
           <a:p>
             <a:pPr algn="ctr">
-              <a:defRPr sz="1600" b="1">
+              <a:defRPr sz="1300" b="1">
+                <a:solidFill>
+                  <a:srgbClr val="0284C7"/>
+                </a:solidFill>
+              </a:defRPr>
+            </a:pPr>
+            <a:r>
+              <a:t>ESTIMATION FLOW: FROM NOISE TO STABILITY</a:t>
+            </a:r>
+          </a:p>
+          <a:p>
+            <a:pPr>
+              <a:defRPr sz="1150" b="1">
                 <a:solidFill>
                   <a:srgbClr val="EA580C"/>
                 </a:solidFill>
               </a:defRPr>
             </a:pPr>
             <a:r>
-              <a:t>The Small-Sample Trap</a:t>
-            </a:r>
-          </a:p>
-          <a:p>
-            <a:pPr>
-              <a:defRPr sz="1200">
-                <a:solidFill>
-                  <a:srgbClr val="0F172A"/>
-                </a:solidFill>
-              </a:defRPr>
-            </a:pPr>
-            <a:r>
-              <a:t>In a 7-game tournament, a 15/30 3-point shooter registers 50%. A swing of just 3 shots drops him to 40%. Evaluating players on raw short-term percentages produces severe tactical misjudgments.</a:t>
+              <a:t>●  1. RAW TOURNAMENT SIGNAL</a:t>
+            </a:r>
+          </a:p>
+          <a:p>
+            <a:pPr>
+              <a:defRPr sz="1050">
+                <a:solidFill>
+                  <a:srgbClr val="475569"/>
+                </a:solidFill>
+              </a:defRPr>
+            </a:pPr>
+            <a:r>
+              <a:t>    7-game sample: 15/30 3PT = 50.0% (Small-Sample Trap)</a:t>
+            </a:r>
+          </a:p>
+          <a:p>
+            <a:pPr>
+              <a:defRPr sz="1150" b="1">
+                <a:solidFill>
+                  <a:srgbClr val="EA580C"/>
+                </a:solidFill>
+              </a:defRPr>
+            </a:pPr>
+            <a:r>
+              <a:t>▼  2. HIGH VARIANCE &amp; NOISE</a:t>
+            </a:r>
+          </a:p>
+          <a:p>
+            <a:pPr>
+              <a:defRPr sz="1050">
+                <a:solidFill>
+                  <a:srgbClr val="475569"/>
+                </a:solidFill>
+              </a:defRPr>
+            </a:pPr>
+            <a:r>
+              <a:t>    A swing of just 3 shots drops 3PT% from 50% to 40%</a:t>
+            </a:r>
+          </a:p>
+          <a:p>
+            <a:pPr>
+              <a:defRPr sz="1150" b="1">
+                <a:solidFill>
+                  <a:srgbClr val="0284C7"/>
+                </a:solidFill>
+              </a:defRPr>
+            </a:pPr>
+            <a:r>
+              <a:t>▼  3. BAYESIAN SHRINKAGE (lambda = 0.75)</a:t>
+            </a:r>
+          </a:p>
+          <a:p>
+            <a:pPr>
+              <a:defRPr sz="1050">
+                <a:solidFill>
+                  <a:srgbClr val="475569"/>
+                </a:solidFill>
+              </a:defRPr>
+            </a:pPr>
+            <a:r>
+              <a:t>    Weighted contraction toward historical career baseline</a:t>
+            </a:r>
+          </a:p>
+          <a:p>
+            <a:pPr>
+              <a:defRPr sz="1150" b="1">
+                <a:solidFill>
+                  <a:srgbClr val="16A34A"/>
+                </a:solidFill>
+              </a:defRPr>
+            </a:pPr>
+            <a:r>
+              <a:t>▼  4. STABILIZED ESTIMATE</a:t>
+            </a:r>
+          </a:p>
+          <a:p>
+            <a:pPr>
+              <a:defRPr sz="1050">
+                <a:solidFill>
+                  <a:srgbClr val="475569"/>
+                </a:solidFill>
+              </a:defRPr>
+            </a:pPr>
+            <a:r>
+              <a:t>    Reliable true skill projection for pre-game tactical planning</a:t>
             </a:r>
           </a:p>
         </p:txBody>
@@ -3586,8 +3670,74 @@
         </p:nvSpPr>
         <p:spPr>
           <a:xfrm>
-            <a:off x="4297680" y="1737360"/>
-            <a:ext cx="3383280" cy="4114800"/>
+            <a:off x="6217920" y="1737360"/>
+            <a:ext cx="5212080" cy="1463040"/>
+          </a:xfrm>
+          <a:prstGeom prst="roundRect">
+            <a:avLst/>
+          </a:prstGeom>
+          <a:solidFill>
+            <a:srgbClr val="121E42"/>
+          </a:solidFill>
+          <a:ln>
+            <a:solidFill>
+              <a:srgbClr val="0284C7"/>
+            </a:solidFill>
+          </a:ln>
+        </p:spPr>
+        <p:style>
+          <a:lnRef idx="1">
+            <a:schemeClr val="accent1"/>
+          </a:lnRef>
+          <a:fillRef idx="3">
+            <a:schemeClr val="accent1"/>
+          </a:fillRef>
+          <a:effectRef idx="2">
+            <a:schemeClr val="accent1"/>
+          </a:effectRef>
+          <a:fontRef idx="minor">
+            <a:schemeClr val="lt1"/>
+          </a:fontRef>
+        </p:style>
+        <p:txBody>
+          <a:bodyPr rtlCol="0" anchor="ctr" lIns="274320" tIns="182880"/>
+          <a:lstStyle/>
+          <a:p>
+            <a:pPr algn="ctr">
+              <a:defRPr sz="1500" b="1">
+                <a:solidFill>
+                  <a:srgbClr val="0284C7"/>
+                </a:solidFill>
+              </a:defRPr>
+            </a:pPr>
+            <a:r>
+              <a:t>lambda = 0.75  |  BAYESIAN SHRINKAGE FACTOR</a:t>
+            </a:r>
+          </a:p>
+          <a:p>
+            <a:pPr>
+              <a:defRPr sz="1100">
+                <a:solidFill>
+                  <a:srgbClr val="F8FAFC"/>
+                </a:solidFill>
+              </a:defRPr>
+            </a:pPr>
+            <a:r>
+              <a:t>Contracts short-sample variance toward 3,767 player career baselines.</a:t>
+            </a:r>
+          </a:p>
+        </p:txBody>
+      </p:sp>
+      <p:sp>
+        <p:nvSpPr>
+          <p:cNvPr id="8" name="Rounded Rectangle 7"/>
+          <p:cNvSpPr/>
+          <p:nvPr/>
+        </p:nvSpPr>
+        <p:spPr>
+          <a:xfrm>
+            <a:off x="6217920" y="3337560"/>
+            <a:ext cx="5212080" cy="1600200"/>
           </a:xfrm>
           <a:prstGeom prst="roundRect">
             <a:avLst/>
@@ -3616,44 +3766,68 @@
           </a:fontRef>
         </p:style>
         <p:txBody>
-          <a:bodyPr rtlCol="0" anchor="ctr" wrap="square" lIns="274320" rIns="274320" tIns="365760"/>
+          <a:bodyPr rtlCol="0" anchor="ctr" lIns="274320" tIns="182880"/>
           <a:lstStyle/>
           <a:p>
             <a:pPr algn="ctr">
-              <a:defRPr sz="1600" b="1">
+              <a:defRPr sz="1200" b="1">
+                <a:solidFill>
+                  <a:srgbClr val="0F172A"/>
+                </a:solidFill>
+              </a:defRPr>
+            </a:pPr>
+            <a:r>
+              <a:t>CONCEPTUAL SHRINKAGE SPECTRUM</a:t>
+            </a:r>
+          </a:p>
+          <a:p>
+            <a:pPr>
+              <a:defRPr sz="1050" b="1">
+                <a:solidFill>
+                  <a:srgbClr val="EA580C"/>
+                </a:solidFill>
+              </a:defRPr>
+            </a:pPr>
+            <a:r>
+              <a:t>• Raw Tournament Estimate (50.0%) -&gt; High Variance / Noise</a:t>
+            </a:r>
+          </a:p>
+          <a:p>
+            <a:pPr>
+              <a:defRPr sz="1050" b="1">
                 <a:solidFill>
                   <a:srgbClr val="0284C7"/>
                 </a:solidFill>
               </a:defRPr>
             </a:pPr>
             <a:r>
-              <a:t>Bayesian Shrinkage (lambda = 0.75)</a:t>
-            </a:r>
-          </a:p>
-          <a:p>
-            <a:pPr>
-              <a:defRPr sz="1200">
-                <a:solidFill>
-                  <a:srgbClr val="0F172A"/>
-                </a:solidFill>
-              </a:defRPr>
-            </a:pPr>
-            <a:r>
-              <a:t>We contract short-sample shooting metrics toward the player's historical career prior weighted by possession volume. High-volume players shrink less; low-volume samples regress toward baseline.</a:t>
-            </a:r>
-          </a:p>
-        </p:txBody>
-      </p:sp>
-      <p:sp>
-        <p:nvSpPr>
-          <p:cNvPr id="8" name="Rounded Rectangle 7"/>
+              <a:t>• Shrunk Stabilized Estimate (38.5%) -&gt; Reliable Game-Plan Prior</a:t>
+            </a:r>
+          </a:p>
+          <a:p>
+            <a:pPr>
+              <a:defRPr sz="1050" b="1">
+                <a:solidFill>
+                  <a:srgbClr val="16A34A"/>
+                </a:solidFill>
+              </a:defRPr>
+            </a:pPr>
+            <a:r>
+              <a:t>• Global Population Mean (34.2%) -&gt; Historical Baseline</a:t>
+            </a:r>
+          </a:p>
+        </p:txBody>
+      </p:sp>
+      <p:sp>
+        <p:nvSpPr>
+          <p:cNvPr id="9" name="Rounded Rectangle 8"/>
           <p:cNvSpPr/>
           <p:nvPr/>
         </p:nvSpPr>
         <p:spPr>
           <a:xfrm>
-            <a:off x="7863840" y="1737360"/>
-            <a:ext cx="3383280" cy="4114800"/>
+            <a:off x="6217920" y="5074920"/>
+            <a:ext cx="5212080" cy="777240"/>
           </a:xfrm>
           <a:prstGeom prst="roundRect">
             <a:avLst/>
@@ -3682,37 +3856,25 @@
           </a:fontRef>
         </p:style>
         <p:txBody>
-          <a:bodyPr rtlCol="0" anchor="ctr" wrap="square" lIns="274320" rIns="274320" tIns="365760"/>
+          <a:bodyPr rtlCol="0" anchor="ctr" lIns="274320" tIns="137160"/>
           <a:lstStyle/>
           <a:p>
             <a:pPr algn="ctr">
-              <a:defRPr sz="1600" b="1">
+              <a:defRPr sz="1050" b="1">
                 <a:solidFill>
                   <a:srgbClr val="16A34A"/>
                 </a:solidFill>
               </a:defRPr>
             </a:pPr>
             <a:r>
-              <a:t>Cluster Bootstrap (B = 5,000)</a:t>
-            </a:r>
-          </a:p>
-          <a:p>
-            <a:pPr>
-              <a:defRPr sz="1200">
-                <a:solidFill>
-                  <a:srgbClr val="0F172A"/>
-                </a:solidFill>
-              </a:defRPr>
-            </a:pPr>
-            <a:r>
-              <a:t>We generate 95% non-parametric confidence bands across 3,767 qualified player campaigns (&gt;= 40 min), providing coaches with realistic uncertainty intervals.</a:t>
-            </a:r>
-          </a:p>
-        </p:txBody>
-      </p:sp>
-      <p:sp>
-        <p:nvSpPr>
-          <p:cNvPr id="9" name="TextBox 8"/>
+              <a:t>Cluster Bootstrap (B = 5,000): Non-parametric 95% confidence intervals across 3,767 qualified campaigns (&gt;=40 min).</a:t>
+            </a:r>
+          </a:p>
+        </p:txBody>
+      </p:sp>
+      <p:sp>
+        <p:nvSpPr>
+          <p:cNvPr id="10" name="TextBox 9"/>
           <p:cNvSpPr txBox="1"/>
           <p:nvPr/>
         </p:nvSpPr>
@@ -3740,7 +3902,7 @@
               </a:defRPr>
             </a:pPr>
             <a:r>
-              <a:t>Longitudinal Asset: Tracking true shooting evolution across legends (Gasol, Nowitzki, Bogdanovic).</a:t>
+              <a:t>Core Principle: Small samples exaggerate hot streaks. Shrinkage restores empirical reality.</a:t>
             </a:r>
           </a:p>
         </p:txBody>
@@ -5046,7 +5208,7 @@
               </a:defRPr>
             </a:pPr>
             <a:r>
-              <a:t>Fold 05 | Train: 2005–2009 Tournaments -&gt; Test: FIBA World Cup 2010 (Out-of-sample)</a:t>
+              <a:t>Fold 05 | Train: 2005-2009 Tournaments -&gt; Test: FIBA World Cup 2010 (Out-of-sample)</a:t>
             </a:r>
           </a:p>
         </p:txBody>
@@ -5100,7 +5262,7 @@
               </a:defRPr>
             </a:pPr>
             <a:r>
-              <a:t>Fold 11 | Train: 2005–2016 Tournaments -&gt; Test: FIBA EuroBasket 2017 (Out-of-sample)</a:t>
+              <a:t>Fold 11 | Train: 2005-2016 Tournaments -&gt; Test: FIBA EuroBasket 2017 (Out-of-sample)</a:t>
             </a:r>
           </a:p>
         </p:txBody>
@@ -5154,7 +5316,7 @@
               </a:defRPr>
             </a:pPr>
             <a:r>
-              <a:t>Fold 17 | Train: 2005–2023 Tournaments -&gt; Test: Paris Olympic Games 2024 (Out-of-sample)</a:t>
+              <a:t>Fold 17 | Train: 2005-2023 Tournaments -&gt; Test: Paris Olympic Games 2024 (Out-of-sample)</a:t>
             </a:r>
           </a:p>
         </p:txBody>
@@ -5320,7 +5482,7 @@
               </a:defRPr>
             </a:pPr>
             <a:r>
-              <a:t>Monte Carlo Tournament Simulation</a:t>
+              <a:t>Monte Carlo Tournament Simulation Engine</a:t>
             </a:r>
           </a:p>
         </p:txBody>
@@ -5355,7 +5517,7 @@
               </a:defRPr>
             </a:pPr>
             <a:r>
-              <a:t>180,000 full-bracket simulations combining calibrated probabilities and ratings.</a:t>
+              <a:t>Simulating full tournament outcome distributions across 180,000 bracket iterations.</a:t>
             </a:r>
           </a:p>
         </p:txBody>
@@ -5368,8 +5530,62 @@
         </p:nvSpPr>
         <p:spPr>
           <a:xfrm>
-            <a:off x="731520" y="1737360"/>
-            <a:ext cx="3383280" cy="4114800"/>
+            <a:off x="731520" y="1645920"/>
+            <a:ext cx="10698480" cy="502920"/>
+          </a:xfrm>
+          <a:prstGeom prst="roundRect">
+            <a:avLst/>
+          </a:prstGeom>
+          <a:solidFill>
+            <a:srgbClr val="121E42"/>
+          </a:solidFill>
+          <a:ln>
+            <a:solidFill>
+              <a:srgbClr val="0284C7"/>
+            </a:solidFill>
+          </a:ln>
+        </p:spPr>
+        <p:style>
+          <a:lnRef idx="1">
+            <a:schemeClr val="accent1"/>
+          </a:lnRef>
+          <a:fillRef idx="3">
+            <a:schemeClr val="accent1"/>
+          </a:fillRef>
+          <a:effectRef idx="2">
+            <a:schemeClr val="accent1"/>
+          </a:effectRef>
+          <a:fontRef idx="minor">
+            <a:schemeClr val="lt1"/>
+          </a:fontRef>
+        </p:style>
+        <p:txBody>
+          <a:bodyPr rtlCol="0" anchor="ctr" lIns="274320"/>
+          <a:lstStyle/>
+          <a:p>
+            <a:pPr algn="ctr">
+              <a:defRPr sz="1200" b="1">
+                <a:solidFill>
+                  <a:srgbClr val="0284C7"/>
+                </a:solidFill>
+              </a:defRPr>
+            </a:pPr>
+            <a:r>
+              <a:t>SIMULATION PIPELINE: Historical Data  -&gt;  Strength Priors  -&gt;  Monte Carlo (180,000)  -&gt;  Probabilistic Outcomes</a:t>
+            </a:r>
+          </a:p>
+        </p:txBody>
+      </p:sp>
+      <p:sp>
+        <p:nvSpPr>
+          <p:cNvPr id="7" name="Rounded Rectangle 6"/>
+          <p:cNvSpPr/>
+          <p:nvPr/>
+        </p:nvSpPr>
+        <p:spPr>
+          <a:xfrm>
+            <a:off x="731520" y="2286000"/>
+            <a:ext cx="5120640" cy="3566160"/>
           </a:xfrm>
           <a:prstGeom prst="roundRect">
             <a:avLst/>
@@ -5398,44 +5614,128 @@
           </a:fontRef>
         </p:style>
         <p:txBody>
-          <a:bodyPr rtlCol="0" anchor="ctr" wrap="square" lIns="274320" rIns="274320" tIns="365760"/>
+          <a:bodyPr rtlCol="0" anchor="ctr" lIns="274320" tIns="182880"/>
           <a:lstStyle/>
           <a:p>
             <a:pPr algn="ctr">
-              <a:defRPr sz="1600" b="1">
+              <a:defRPr sz="1300" b="1">
+                <a:solidFill>
+                  <a:srgbClr val="0F172A"/>
+                </a:solidFill>
+              </a:defRPr>
+            </a:pPr>
+            <a:r>
+              <a:t>DYNAMIC TOURNAMENT BRACKET FLOW</a:t>
+            </a:r>
+          </a:p>
+          <a:p>
+            <a:pPr>
+              <a:defRPr sz="1100" b="1">
                 <a:solidFill>
                   <a:srgbClr val="0284C7"/>
                 </a:solidFill>
               </a:defRPr>
             </a:pPr>
             <a:r>
-              <a:t>Dynamic Bracket Flow</a:t>
-            </a:r>
-          </a:p>
-          <a:p>
-            <a:pPr>
-              <a:defRPr sz="1200">
-                <a:solidFill>
-                  <a:srgbClr val="0F172A"/>
-                </a:solidFill>
-              </a:defRPr>
-            </a:pPr>
-            <a:r>
-              <a:t>Simulates group stages, tie-breakers, and knockout brackets accounting for match sequence and cumulative fatigue.</a:t>
-            </a:r>
-          </a:p>
-        </p:txBody>
-      </p:sp>
-      <p:sp>
-        <p:nvSpPr>
-          <p:cNvPr id="7" name="Rounded Rectangle 6"/>
+              <a:t>▶  Round of 16</a:t>
+            </a:r>
+          </a:p>
+          <a:p>
+            <a:pPr>
+              <a:defRPr sz="1000">
+                <a:solidFill>
+                  <a:srgbClr val="475569"/>
+                </a:solidFill>
+              </a:defRPr>
+            </a:pPr>
+            <a:r>
+              <a:t>    Match 01  |  Match 02  |  Match 03  |  Match 04</a:t>
+            </a:r>
+          </a:p>
+          <a:p>
+            <a:pPr>
+              <a:defRPr sz="1100" b="1">
+                <a:solidFill>
+                  <a:srgbClr val="0284C7"/>
+                </a:solidFill>
+              </a:defRPr>
+            </a:pPr>
+            <a:r>
+              <a:t>▶  Quarterfinals</a:t>
+            </a:r>
+          </a:p>
+          <a:p>
+            <a:pPr>
+              <a:defRPr sz="1000">
+                <a:solidFill>
+                  <a:srgbClr val="475569"/>
+                </a:solidFill>
+              </a:defRPr>
+            </a:pPr>
+            <a:r>
+              <a:t>    QF 01  |  QF 02</a:t>
+            </a:r>
+          </a:p>
+          <a:p>
+            <a:pPr>
+              <a:defRPr sz="1100" b="1">
+                <a:solidFill>
+                  <a:srgbClr val="0284C7"/>
+                </a:solidFill>
+              </a:defRPr>
+            </a:pPr>
+            <a:r>
+              <a:t>▶  Semifinals</a:t>
+            </a:r>
+          </a:p>
+          <a:p>
+            <a:pPr>
+              <a:defRPr sz="1000">
+                <a:solidFill>
+                  <a:srgbClr val="475569"/>
+                </a:solidFill>
+              </a:defRPr>
+            </a:pPr>
+            <a:r>
+              <a:t>    SF 01  |  SF 02</a:t>
+            </a:r>
+          </a:p>
+          <a:p>
+            <a:pPr>
+              <a:defRPr sz="1100" b="1">
+                <a:solidFill>
+                  <a:srgbClr val="0284C7"/>
+                </a:solidFill>
+              </a:defRPr>
+            </a:pPr>
+            <a:r>
+              <a:t>▶  Final &amp; Podium</a:t>
+            </a:r>
+          </a:p>
+          <a:p>
+            <a:pPr>
+              <a:defRPr sz="1000">
+                <a:solidFill>
+                  <a:srgbClr val="475569"/>
+                </a:solidFill>
+              </a:defRPr>
+            </a:pPr>
+            <a:r>
+              <a:t>    CHAMPION  |  MEDAL TREE</a:t>
+            </a:r>
+          </a:p>
+        </p:txBody>
+      </p:sp>
+      <p:sp>
+        <p:nvSpPr>
+          <p:cNvPr id="8" name="Rounded Rectangle 7"/>
           <p:cNvSpPr/>
           <p:nvPr/>
         </p:nvSpPr>
         <p:spPr>
           <a:xfrm>
-            <a:off x="4297680" y="1737360"/>
-            <a:ext cx="3383280" cy="4114800"/>
+            <a:off x="6217920" y="2286000"/>
+            <a:ext cx="5212080" cy="1115568"/>
           </a:xfrm>
           <a:prstGeom prst="roundRect">
             <a:avLst/>
@@ -5464,44 +5764,44 @@
           </a:fontRef>
         </p:style>
         <p:txBody>
-          <a:bodyPr rtlCol="0" anchor="ctr" wrap="square" lIns="274320" rIns="274320" tIns="365760"/>
+          <a:bodyPr rtlCol="0" anchor="ctr" lIns="274320" tIns="164592"/>
           <a:lstStyle/>
           <a:p>
             <a:pPr algn="ctr">
-              <a:defRPr sz="1600" b="1">
-                <a:solidFill>
-                  <a:srgbClr val="EA580C"/>
-                </a:solidFill>
-              </a:defRPr>
-            </a:pPr>
-            <a:r>
-              <a:t>Shrinkage toward Mean</a:t>
-            </a:r>
-          </a:p>
-          <a:p>
-            <a:pPr>
-              <a:defRPr sz="1200">
+              <a:defRPr sz="1400" b="1">
+                <a:solidFill>
+                  <a:srgbClr val="0284C7"/>
+                </a:solidFill>
+              </a:defRPr>
+            </a:pPr>
+            <a:r>
+              <a:t>180,000  |  BRACKET ITERATIONS</a:t>
+            </a:r>
+          </a:p>
+          <a:p>
+            <a:pPr>
+              <a:defRPr sz="1050">
                 <a:solidFill>
                   <a:srgbClr val="0F172A"/>
                 </a:solidFill>
               </a:defRPr>
             </a:pPr>
             <a:r>
-              <a:t>Applies Bayesian shrinkage to pre-tournament ratings to prevent over-reacting to preliminary round upsets.</a:t>
-            </a:r>
-          </a:p>
-        </p:txBody>
-      </p:sp>
-      <p:sp>
-        <p:nvSpPr>
-          <p:cNvPr id="8" name="Rounded Rectangle 7"/>
+              <a:t>Full dynamic bracket simulations accounting for match sequence and cumulative fatigue.</a:t>
+            </a:r>
+          </a:p>
+        </p:txBody>
+      </p:sp>
+      <p:sp>
+        <p:nvSpPr>
+          <p:cNvPr id="9" name="Rounded Rectangle 8"/>
           <p:cNvSpPr/>
           <p:nvPr/>
         </p:nvSpPr>
         <p:spPr>
           <a:xfrm>
-            <a:off x="7863840" y="1737360"/>
-            <a:ext cx="3383280" cy="4114800"/>
+            <a:off x="6217920" y="3502152"/>
+            <a:ext cx="5212080" cy="1115568"/>
           </a:xfrm>
           <a:prstGeom prst="roundRect">
             <a:avLst/>
@@ -5530,37 +5830,103 @@
           </a:fontRef>
         </p:style>
         <p:txBody>
-          <a:bodyPr rtlCol="0" anchor="ctr" wrap="square" lIns="274320" rIns="274320" tIns="365760"/>
+          <a:bodyPr rtlCol="0" anchor="ctr" lIns="274320" tIns="164592"/>
           <a:lstStyle/>
           <a:p>
             <a:pPr algn="ctr">
-              <a:defRPr sz="1600" b="1">
+              <a:defRPr sz="1400" b="1">
+                <a:solidFill>
+                  <a:srgbClr val="EA580C"/>
+                </a:solidFill>
+              </a:defRPr>
+            </a:pPr>
+            <a:r>
+              <a:t>lambda = 0.75  |  BAYESIAN SHRINKAGE</a:t>
+            </a:r>
+          </a:p>
+          <a:p>
+            <a:pPr>
+              <a:defRPr sz="1050">
+                <a:solidFill>
+                  <a:srgbClr val="0F172A"/>
+                </a:solidFill>
+              </a:defRPr>
+            </a:pPr>
+            <a:r>
+              <a:t>Prevents over-reacting to preliminary round group-stage upsets.</a:t>
+            </a:r>
+          </a:p>
+        </p:txBody>
+      </p:sp>
+      <p:sp>
+        <p:nvSpPr>
+          <p:cNvPr id="10" name="Rounded Rectangle 9"/>
+          <p:cNvSpPr/>
+          <p:nvPr/>
+        </p:nvSpPr>
+        <p:spPr>
+          <a:xfrm>
+            <a:off x="6217920" y="4718304"/>
+            <a:ext cx="5212080" cy="1115568"/>
+          </a:xfrm>
+          <a:prstGeom prst="roundRect">
+            <a:avLst/>
+          </a:prstGeom>
+          <a:solidFill>
+            <a:srgbClr val="FFFFFF"/>
+          </a:solidFill>
+          <a:ln>
+            <a:solidFill>
+              <a:srgbClr val="E2E8F0"/>
+            </a:solidFill>
+          </a:ln>
+        </p:spPr>
+        <p:style>
+          <a:lnRef idx="1">
+            <a:schemeClr val="accent1"/>
+          </a:lnRef>
+          <a:fillRef idx="3">
+            <a:schemeClr val="accent1"/>
+          </a:fillRef>
+          <a:effectRef idx="2">
+            <a:schemeClr val="accent1"/>
+          </a:effectRef>
+          <a:fontRef idx="minor">
+            <a:schemeClr val="lt1"/>
+          </a:fontRef>
+        </p:style>
+        <p:txBody>
+          <a:bodyPr rtlCol="0" anchor="ctr" lIns="274320" tIns="164592"/>
+          <a:lstStyle/>
+          <a:p>
+            <a:pPr algn="ctr">
+              <a:defRPr sz="1400" b="1">
                 <a:solidFill>
                   <a:srgbClr val="16A34A"/>
                 </a:solidFill>
               </a:defRPr>
             </a:pPr>
             <a:r>
-              <a:t>Scenario Sensitivity</a:t>
-            </a:r>
-          </a:p>
-          <a:p>
-            <a:pPr>
-              <a:defRPr sz="1200">
+              <a:t>PROBABILISTIC  |  OUTCOME DISTRIBUTIONS</a:t>
+            </a:r>
+          </a:p>
+          <a:p>
+            <a:pPr>
+              <a:defRPr sz="1050">
                 <a:solidFill>
                   <a:srgbClr val="0F172A"/>
                 </a:solidFill>
               </a:defRPr>
             </a:pPr>
             <a:r>
-              <a:t>Enables coaching staff to test 'what-if' roster changes or key injury impacts before tournament commencement.</a:t>
-            </a:r>
-          </a:p>
-        </p:txBody>
-      </p:sp>
-      <p:sp>
-        <p:nvSpPr>
-          <p:cNvPr id="9" name="TextBox 8"/>
+              <a:t>Outputs conditional podium probability trees rather than fragile single-winner picks.</a:t>
+            </a:r>
+          </a:p>
+        </p:txBody>
+      </p:sp>
+      <p:sp>
+        <p:nvSpPr>
+          <p:cNvPr id="11" name="TextBox 10"/>
           <p:cNvSpPr txBox="1"/>
           <p:nvPr/>
         </p:nvSpPr>
@@ -5588,7 +5954,7 @@
               </a:defRPr>
             </a:pPr>
             <a:r>
-              <a:t>Output: Probabilistic medal probabilities and conditional matchup trees.</a:t>
+              <a:t>Modeling Focus: The system simulates outcome distributions, not deterministic winners.</a:t>
             </a:r>
           </a:p>
         </p:txBody>
@@ -5684,7 +6050,7 @@
               </a:defRPr>
             </a:pPr>
             <a:r>
-              <a:t>DECISION SUPPORT</a:t>
+              <a:t>DECISION SUPPORT WORKSPACE</a:t>
             </a:r>
           </a:p>
         </p:txBody>
@@ -5719,7 +6085,7 @@
               </a:defRPr>
             </a:pPr>
             <a:r>
-              <a:t>Interactive Workspace &amp; Anti-Hindsight Mode</a:t>
+              <a:t>Interactive Workspace &amp; Anti-Hindsight Protocol</a:t>
             </a:r>
           </a:p>
         </p:txBody>
@@ -5754,7 +6120,7 @@
               </a:defRPr>
             </a:pPr>
             <a:r>
-              <a:t>Isolating pre-game evidence states at T-30, T-7, T-1, and Game Day to eliminate hindsight bias.</a:t>
+              <a:t>Isolating pre-game evidence from post-game outcomes to eliminate hindsight bias.</a:t>
             </a:r>
           </a:p>
         </p:txBody>
@@ -5767,8 +6133,176 @@
         </p:nvSpPr>
         <p:spPr>
           <a:xfrm>
-            <a:off x="731520" y="1737360"/>
-            <a:ext cx="3383280" cy="4114800"/>
+            <a:off x="731520" y="1645920"/>
+            <a:ext cx="10698480" cy="502920"/>
+          </a:xfrm>
+          <a:prstGeom prst="roundRect">
+            <a:avLst/>
+          </a:prstGeom>
+          <a:solidFill>
+            <a:srgbClr val="121E42"/>
+          </a:solidFill>
+          <a:ln>
+            <a:solidFill>
+              <a:srgbClr val="0284C7"/>
+            </a:solidFill>
+          </a:ln>
+        </p:spPr>
+        <p:style>
+          <a:lnRef idx="1">
+            <a:schemeClr val="accent1"/>
+          </a:lnRef>
+          <a:fillRef idx="3">
+            <a:schemeClr val="accent1"/>
+          </a:fillRef>
+          <a:effectRef idx="2">
+            <a:schemeClr val="accent1"/>
+          </a:effectRef>
+          <a:fontRef idx="minor">
+            <a:schemeClr val="lt1"/>
+          </a:fontRef>
+        </p:style>
+        <p:txBody>
+          <a:bodyPr rtlCol="0" anchor="ctr" lIns="274320"/>
+          <a:lstStyle/>
+          <a:p>
+            <a:pPr algn="ctr">
+              <a:defRPr sz="1200" b="1">
+                <a:solidFill>
+                  <a:srgbClr val="0284C7"/>
+                </a:solidFill>
+              </a:defRPr>
+            </a:pPr>
+            <a:r>
+              <a:t>💻  ANALYST DECISION WORKSPACE  |  Streamlit Decision Support Engine</a:t>
+            </a:r>
+          </a:p>
+        </p:txBody>
+      </p:sp>
+      <p:sp>
+        <p:nvSpPr>
+          <p:cNvPr id="7" name="Rounded Rectangle 6"/>
+          <p:cNvSpPr/>
+          <p:nvPr/>
+        </p:nvSpPr>
+        <p:spPr>
+          <a:xfrm>
+            <a:off x="731520" y="2286000"/>
+            <a:ext cx="2926080" cy="3566160"/>
+          </a:xfrm>
+          <a:prstGeom prst="roundRect">
+            <a:avLst/>
+          </a:prstGeom>
+          <a:solidFill>
+            <a:srgbClr val="0A1128"/>
+          </a:solidFill>
+          <a:ln>
+            <a:solidFill>
+              <a:srgbClr val="121E42"/>
+            </a:solidFill>
+          </a:ln>
+        </p:spPr>
+        <p:style>
+          <a:lnRef idx="1">
+            <a:schemeClr val="accent1"/>
+          </a:lnRef>
+          <a:fillRef idx="3">
+            <a:schemeClr val="accent1"/>
+          </a:fillRef>
+          <a:effectRef idx="2">
+            <a:schemeClr val="accent1"/>
+          </a:effectRef>
+          <a:fontRef idx="minor">
+            <a:schemeClr val="lt1"/>
+          </a:fontRef>
+        </p:style>
+        <p:txBody>
+          <a:bodyPr rtlCol="0" anchor="ctr" lIns="228600" tIns="182880"/>
+          <a:lstStyle/>
+          <a:p>
+            <a:pPr algn="ctr">
+              <a:defRPr sz="1100" b="1">
+                <a:solidFill>
+                  <a:srgbClr val="0284C7"/>
+                </a:solidFill>
+              </a:defRPr>
+            </a:pPr>
+            <a:r>
+              <a:t>APP FILTERS</a:t>
+            </a:r>
+          </a:p>
+          <a:p>
+            <a:pPr>
+              <a:defRPr sz="1000">
+                <a:solidFill>
+                  <a:srgbClr val="F8FAFC"/>
+                </a:solidFill>
+              </a:defRPr>
+            </a:pPr>
+            <a:r>
+              <a:t>• Target Match: Spain vs USA</a:t>
+            </a:r>
+          </a:p>
+          <a:p>
+            <a:pPr>
+              <a:defRPr sz="1000">
+                <a:solidFill>
+                  <a:srgbClr val="F8FAFC"/>
+                </a:solidFill>
+              </a:defRPr>
+            </a:pPr>
+            <a:r>
+              <a:t>• Checkpoint: T-1 (Pre-Game)</a:t>
+            </a:r>
+          </a:p>
+          <a:p>
+            <a:pPr>
+              <a:defRPr sz="1000">
+                <a:solidFill>
+                  <a:srgbClr val="F8FAFC"/>
+                </a:solidFill>
+              </a:defRPr>
+            </a:pPr>
+            <a:r>
+              <a:t>• Evidence: Four Factors &amp; Drop</a:t>
+            </a:r>
+          </a:p>
+          <a:p>
+            <a:pPr>
+              <a:defRPr sz="1000">
+                <a:solidFill>
+                  <a:srgbClr val="F8FAFC"/>
+                </a:solidFill>
+              </a:defRPr>
+            </a:pPr>
+            <a:r>
+              <a:t>• Roster State: Canonical 2008</a:t>
+            </a:r>
+          </a:p>
+          <a:p>
+            <a:pPr>
+              <a:defRPr sz="1000">
+                <a:solidFill>
+                  <a:srgbClr val="F8FAFC"/>
+                </a:solidFill>
+              </a:defRPr>
+            </a:pPr>
+            <a:r>
+              <a:t>• Status: ANTI-HINDSIGHT ACTIVE</a:t>
+            </a:r>
+          </a:p>
+        </p:txBody>
+      </p:sp>
+      <p:sp>
+        <p:nvSpPr>
+          <p:cNvPr id="8" name="Rounded Rectangle 7"/>
+          <p:cNvSpPr/>
+          <p:nvPr/>
+        </p:nvSpPr>
+        <p:spPr>
+          <a:xfrm>
+            <a:off x="3840480" y="2286000"/>
+            <a:ext cx="3931920" cy="2560320"/>
           </a:xfrm>
           <a:prstGeom prst="roundRect">
             <a:avLst/>
@@ -5778,7 +6312,7 @@
           </a:solidFill>
           <a:ln>
             <a:solidFill>
-              <a:srgbClr val="E2E8F0"/>
+              <a:srgbClr val="16A34A"/>
             </a:solidFill>
           </a:ln>
         </p:spPr>
@@ -5797,44 +6331,80 @@
           </a:fontRef>
         </p:style>
         <p:txBody>
-          <a:bodyPr rtlCol="0" anchor="ctr" wrap="square" lIns="274320" rIns="274320" tIns="365760"/>
+          <a:bodyPr rtlCol="0" anchor="ctr" lIns="228600" tIns="182880"/>
           <a:lstStyle/>
           <a:p>
             <a:pPr algn="ctr">
-              <a:defRPr sz="1600" b="1">
-                <a:solidFill>
-                  <a:srgbClr val="0284C7"/>
-                </a:solidFill>
-              </a:defRPr>
-            </a:pPr>
-            <a:r>
-              <a:t>Temporal Quarantine</a:t>
-            </a:r>
-          </a:p>
-          <a:p>
-            <a:pPr>
-              <a:defRPr sz="1200">
+              <a:defRPr sz="1200" b="1">
+                <a:solidFill>
+                  <a:srgbClr val="16A34A"/>
+                </a:solidFill>
+              </a:defRPr>
+            </a:pPr>
+            <a:r>
+              <a:t>PRE-GAME EVIDENCE (AVAILABLE)</a:t>
+            </a:r>
+          </a:p>
+          <a:p>
+            <a:pPr>
+              <a:defRPr sz="1000">
                 <a:solidFill>
                   <a:srgbClr val="0F172A"/>
                 </a:solidFill>
               </a:defRPr>
             </a:pPr>
             <a:r>
-              <a:t>The system hides post-game outcomes, forcing the analyst to evaluate the exact pre-game information available before tip-off.</a:t>
-            </a:r>
-          </a:p>
-        </p:txBody>
-      </p:sp>
-      <p:sp>
-        <p:nvSpPr>
-          <p:cNvPr id="7" name="Rounded Rectangle 6"/>
+              <a:t>• Pace-neutral Four Factors (+4.2 Net Rating half-court)</a:t>
+            </a:r>
+          </a:p>
+          <a:p>
+            <a:pPr>
+              <a:defRPr sz="1000">
+                <a:solidFill>
+                  <a:srgbClr val="0F172A"/>
+                </a:solidFill>
+              </a:defRPr>
+            </a:pPr>
+            <a:r>
+              <a:t>• Opponent defense alert: Center deep drop on P&amp;R</a:t>
+            </a:r>
+          </a:p>
+          <a:p>
+            <a:pPr>
+              <a:defRPr sz="1000">
+                <a:solidFill>
+                  <a:srgbClr val="0F172A"/>
+                </a:solidFill>
+              </a:defRPr>
+            </a:pPr>
+            <a:r>
+              <a:t>• Longitudinal shooting priors (lambda = 0.75 stabilized)</a:t>
+            </a:r>
+          </a:p>
+          <a:p>
+            <a:pPr>
+              <a:defRPr sz="1000">
+                <a:solidFill>
+                  <a:srgbClr val="0F172A"/>
+                </a:solidFill>
+              </a:defRPr>
+            </a:pPr>
+            <a:r>
+              <a:t>• Functional archetype matchup synergy &amp; rim delta</a:t>
+            </a:r>
+          </a:p>
+        </p:txBody>
+      </p:sp>
+      <p:sp>
+        <p:nvSpPr>
+          <p:cNvPr id="9" name="Rounded Rectangle 8"/>
           <p:cNvSpPr/>
           <p:nvPr/>
         </p:nvSpPr>
         <p:spPr>
           <a:xfrm>
-            <a:off x="4297680" y="1737360"/>
-            <a:ext cx="3383280" cy="4114800"/>
+            <a:off x="7955279" y="2286000"/>
+            <a:ext cx="3474720" cy="2560320"/>
           </a:xfrm>
           <a:prstGeom prst="roundRect">
             <a:avLst/>
@@ -5844,7 +6414,7 @@
           </a:solidFill>
           <a:ln>
             <a:solidFill>
-              <a:srgbClr val="E2E8F0"/>
+              <a:srgbClr val="EA580C"/>
             </a:solidFill>
           </a:ln>
         </p:spPr>
@@ -5863,54 +6433,90 @@
           </a:fontRef>
         </p:style>
         <p:txBody>
-          <a:bodyPr rtlCol="0" anchor="ctr" wrap="square" lIns="274320" rIns="274320" tIns="365760"/>
+          <a:bodyPr rtlCol="0" anchor="ctr" lIns="228600" tIns="182880"/>
           <a:lstStyle/>
           <a:p>
             <a:pPr algn="ctr">
-              <a:defRPr sz="1600" b="1">
+              <a:defRPr sz="1200" b="1">
                 <a:solidFill>
                   <a:srgbClr val="EA580C"/>
                 </a:solidFill>
               </a:defRPr>
             </a:pPr>
             <a:r>
-              <a:t>Multi-Layer Evidence Matrix</a:t>
-            </a:r>
-          </a:p>
-          <a:p>
-            <a:pPr>
-              <a:defRPr sz="1200">
-                <a:solidFill>
-                  <a:srgbClr val="0F172A"/>
-                </a:solidFill>
-              </a:defRPr>
-            </a:pPr>
-            <a:r>
-              <a:t>Synthesizes Four Factors, shot zones, archetype matchups, and predictive ratings in one unified view.</a:t>
-            </a:r>
-          </a:p>
-        </p:txBody>
-      </p:sp>
-      <p:sp>
-        <p:nvSpPr>
-          <p:cNvPr id="8" name="Rounded Rectangle 7"/>
+              <a:t>POST-GAME (QUARANTINED)</a:t>
+            </a:r>
+          </a:p>
+          <a:p>
+            <a:pPr>
+              <a:defRPr sz="1000">
+                <a:solidFill>
+                  <a:srgbClr val="475569"/>
+                </a:solidFill>
+              </a:defRPr>
+            </a:pPr>
+            <a:r>
+              <a:t>[QUARANTINED POST-GAME INFORMATION]</a:t>
+            </a:r>
+          </a:p>
+          <a:p>
+            <a:pPr>
+              <a:defRPr sz="1000">
+                <a:solidFill>
+                  <a:srgbClr val="475569"/>
+                </a:solidFill>
+              </a:defRPr>
+            </a:pPr>
+            <a:r>
+              <a:t>- Final score &amp; official boxscore totals</a:t>
+            </a:r>
+          </a:p>
+          <a:p>
+            <a:pPr>
+              <a:defRPr sz="1000">
+                <a:solidFill>
+                  <a:srgbClr val="475569"/>
+                </a:solidFill>
+              </a:defRPr>
+            </a:pPr>
+            <a:r>
+              <a:t>- Shooting percentages of current game</a:t>
+            </a:r>
+          </a:p>
+          <a:p>
+            <a:pPr>
+              <a:defRPr sz="1000">
+                <a:solidFill>
+                  <a:srgbClr val="475569"/>
+                </a:solidFill>
+              </a:defRPr>
+            </a:pPr>
+            <a:r>
+              <a:t>- Post-hoc tactical rationalizations</a:t>
+            </a:r>
+          </a:p>
+        </p:txBody>
+      </p:sp>
+      <p:sp>
+        <p:nvSpPr>
+          <p:cNvPr id="10" name="Rounded Rectangle 9"/>
           <p:cNvSpPr/>
           <p:nvPr/>
         </p:nvSpPr>
         <p:spPr>
           <a:xfrm>
-            <a:off x="7863840" y="1737360"/>
-            <a:ext cx="3383280" cy="4114800"/>
+            <a:off x="3840480" y="4983480"/>
+            <a:ext cx="7589520" cy="868680"/>
           </a:xfrm>
           <a:prstGeom prst="roundRect">
             <a:avLst/>
           </a:prstGeom>
           <a:solidFill>
-            <a:srgbClr val="FFFFFF"/>
+            <a:srgbClr val="121E42"/>
           </a:solidFill>
           <a:ln>
             <a:solidFill>
-              <a:srgbClr val="E2E8F0"/>
+              <a:srgbClr val="0284C7"/>
             </a:solidFill>
           </a:ln>
         </p:spPr>
@@ -5929,37 +6535,25 @@
           </a:fontRef>
         </p:style>
         <p:txBody>
-          <a:bodyPr rtlCol="0" anchor="ctr" wrap="square" lIns="274320" rIns="274320" tIns="365760"/>
+          <a:bodyPr rtlCol="0" anchor="ctr" lIns="274320" tIns="164592"/>
           <a:lstStyle/>
           <a:p>
             <a:pPr algn="ctr">
-              <a:defRPr sz="1600" b="1">
-                <a:solidFill>
-                  <a:srgbClr val="16A34A"/>
-                </a:solidFill>
-              </a:defRPr>
-            </a:pPr>
-            <a:r>
-              <a:t>Automated Inconsistency Alerts</a:t>
-            </a:r>
-          </a:p>
-          <a:p>
-            <a:pPr>
-              <a:defRPr sz="1200">
-                <a:solidFill>
-                  <a:srgbClr val="0F172A"/>
-                </a:solidFill>
-              </a:defRPr>
-            </a:pPr>
-            <a:r>
-              <a:t>Flags statistical red flags (e.g. low-sample shooting spikes vs career priors) before they reach the coach.</a:t>
-            </a:r>
-          </a:p>
-        </p:txBody>
-      </p:sp>
-      <p:sp>
-        <p:nvSpPr>
-          <p:cNvPr id="9" name="TextBox 8"/>
+              <a:defRPr sz="1100" b="1">
+                <a:solidFill>
+                  <a:srgbClr val="F8FAFC"/>
+                </a:solidFill>
+              </a:defRPr>
+            </a:pPr>
+            <a:r>
+              <a:t>ANTI-HINDSIGHT AUDIT TRAIL:  T-7 Pre-Brief  -&gt;  T-1 Decision Log  -&gt;  Game Tip-Off  -&gt;  Outcome Revealed  -&gt;  Post-Game Audit</a:t>
+            </a:r>
+          </a:p>
+        </p:txBody>
+      </p:sp>
+      <p:sp>
+        <p:nvSpPr>
+          <p:cNvPr id="11" name="TextBox 10"/>
           <p:cNvSpPr txBox="1"/>
           <p:nvPr/>
         </p:nvSpPr>
@@ -5987,7 +6581,7 @@
               </a:defRPr>
             </a:pPr>
             <a:r>
-              <a:t>Interactive Tool: Streamlit workspace runnable locally with `streamlit run`.</a:t>
+              <a:t>Anti-Hindsight Guarantee: Analyst decisions are permanently timestamped before tip-off.</a:t>
             </a:r>
           </a:p>
         </p:txBody>
@@ -10594,7 +11188,7 @@
               </a:defRPr>
             </a:pPr>
             <a:r>
-              <a:t>Operational Value by Organizational Role</a:t>
+              <a:t>Operational Value by Basketball Role</a:t>
             </a:r>
           </a:p>
         </p:txBody>
@@ -10642,8 +11236,62 @@
         </p:nvSpPr>
         <p:spPr>
           <a:xfrm>
-            <a:off x="731520" y="1737360"/>
-            <a:ext cx="3383280" cy="4114800"/>
+            <a:off x="731520" y="1645920"/>
+            <a:ext cx="10698480" cy="502920"/>
+          </a:xfrm>
+          <a:prstGeom prst="roundRect">
+            <a:avLst/>
+          </a:prstGeom>
+          <a:solidFill>
+            <a:srgbClr val="121E42"/>
+          </a:solidFill>
+          <a:ln>
+            <a:solidFill>
+              <a:srgbClr val="0284C7"/>
+            </a:solidFill>
+          </a:ln>
+        </p:spPr>
+        <p:style>
+          <a:lnRef idx="1">
+            <a:schemeClr val="accent1"/>
+          </a:lnRef>
+          <a:fillRef idx="3">
+            <a:schemeClr val="accent1"/>
+          </a:fillRef>
+          <a:effectRef idx="2">
+            <a:schemeClr val="accent1"/>
+          </a:effectRef>
+          <a:fontRef idx="minor">
+            <a:schemeClr val="lt1"/>
+          </a:fontRef>
+        </p:style>
+        <p:txBody>
+          <a:bodyPr rtlCol="0" anchor="ctr" lIns="274320"/>
+          <a:lstStyle/>
+          <a:p>
+            <a:pPr algn="ctr">
+              <a:defRPr sz="1200" b="1">
+                <a:solidFill>
+                  <a:srgbClr val="0284C7"/>
+                </a:solidFill>
+              </a:defRPr>
+            </a:pPr>
+            <a:r>
+              <a:t>ORGANIZATIONAL IMPACT:  BASKETBALL CLUB DECISION ECOSYSTEM</a:t>
+            </a:r>
+          </a:p>
+        </p:txBody>
+      </p:sp>
+      <p:sp>
+        <p:nvSpPr>
+          <p:cNvPr id="7" name="Rounded Rectangle 6"/>
+          <p:cNvSpPr/>
+          <p:nvPr/>
+        </p:nvSpPr>
+        <p:spPr>
+          <a:xfrm>
+            <a:off x="731520" y="2286000"/>
+            <a:ext cx="3383280" cy="2743200"/>
           </a:xfrm>
           <a:prstGeom prst="roundRect">
             <a:avLst/>
@@ -10672,44 +11320,80 @@
           </a:fontRef>
         </p:style>
         <p:txBody>
-          <a:bodyPr rtlCol="0" anchor="ctr" wrap="square" lIns="274320" rIns="274320" tIns="365760"/>
+          <a:bodyPr rtlCol="0" anchor="ctr" lIns="228600" rIns="228600" tIns="228600"/>
           <a:lstStyle/>
           <a:p>
             <a:pPr algn="ctr">
-              <a:defRPr sz="1600" b="1">
+              <a:defRPr sz="1300" b="1">
                 <a:solidFill>
                   <a:srgbClr val="0284C7"/>
                 </a:solidFill>
               </a:defRPr>
             </a:pPr>
             <a:r>
-              <a:t>Head Coach &amp; Assistants</a:t>
-            </a:r>
-          </a:p>
-          <a:p>
-            <a:pPr>
-              <a:defRPr sz="1200">
+              <a:t>HEAD COACH &amp; STAFF</a:t>
+            </a:r>
+          </a:p>
+          <a:p>
+            <a:pPr>
+              <a:defRPr sz="1100" b="1">
                 <a:solidFill>
                   <a:srgbClr val="0F172A"/>
                 </a:solidFill>
               </a:defRPr>
             </a:pPr>
             <a:r>
-              <a:t>Saves 15+ hours/week by synthesizing rival scouting into 1.5-page pre-game briefs with Four Factors and P&amp;R drop alerts.</a:t>
-            </a:r>
-          </a:p>
-        </p:txBody>
-      </p:sp>
-      <p:sp>
-        <p:nvSpPr>
-          <p:cNvPr id="7" name="Rounded Rectangle 6"/>
+              <a:t>"WHAT TO CHANGE"</a:t>
+            </a:r>
+          </a:p>
+          <a:p>
+            <a:pPr>
+              <a:defRPr sz="1050">
+                <a:solidFill>
+                  <a:srgbClr val="475569"/>
+                </a:solidFill>
+              </a:defRPr>
+            </a:pPr>
+            <a:r>
+              <a:t>• Pre-game 1.5-page coaching briefs</a:t>
+            </a:r>
+          </a:p>
+          <a:p>
+            <a:pPr>
+              <a:defRPr sz="1050">
+                <a:solidFill>
+                  <a:srgbClr val="475569"/>
+                </a:solidFill>
+              </a:defRPr>
+            </a:pPr>
+            <a:r>
+              <a:t>• Opponent P&amp;R drop coverage alerts</a:t>
+            </a:r>
+          </a:p>
+          <a:p>
+            <a:pPr>
+              <a:defRPr sz="1050">
+                <a:solidFill>
+                  <a:srgbClr val="475569"/>
+                </a:solidFill>
+              </a:defRPr>
+            </a:pPr>
+            <a:r>
+              <a:t>• Pace &amp; possession targets (&lt;= 72 poss)</a:t>
+            </a:r>
+          </a:p>
+        </p:txBody>
+      </p:sp>
+      <p:sp>
+        <p:nvSpPr>
+          <p:cNvPr id="8" name="Rounded Rectangle 7"/>
           <p:cNvSpPr/>
           <p:nvPr/>
         </p:nvSpPr>
         <p:spPr>
           <a:xfrm>
-            <a:off x="4297680" y="1737360"/>
-            <a:ext cx="3383280" cy="4114800"/>
+            <a:off x="4297680" y="2286000"/>
+            <a:ext cx="3383280" cy="2743200"/>
           </a:xfrm>
           <a:prstGeom prst="roundRect">
             <a:avLst/>
@@ -10738,44 +11422,80 @@
           </a:fontRef>
         </p:style>
         <p:txBody>
-          <a:bodyPr rtlCol="0" anchor="ctr" wrap="square" lIns="274320" rIns="274320" tIns="365760"/>
+          <a:bodyPr rtlCol="0" anchor="ctr" lIns="228600" rIns="228600" tIns="228600"/>
           <a:lstStyle/>
           <a:p>
             <a:pPr algn="ctr">
-              <a:defRPr sz="1600" b="1">
+              <a:defRPr sz="1300" b="1">
                 <a:solidFill>
                   <a:srgbClr val="EA580C"/>
                 </a:solidFill>
               </a:defRPr>
             </a:pPr>
             <a:r>
-              <a:t>Sporting Director &amp; Scouts</a:t>
-            </a:r>
-          </a:p>
-          <a:p>
-            <a:pPr>
-              <a:defRPr sz="1200">
+              <a:t>SCOUTING DEPARTMENT</a:t>
+            </a:r>
+          </a:p>
+          <a:p>
+            <a:pPr>
+              <a:defRPr sz="1100" b="1">
                 <a:solidFill>
                   <a:srgbClr val="0F172A"/>
                 </a:solidFill>
               </a:defRPr>
             </a:pPr>
             <a:r>
-              <a:t>Filters out small-sample shooting noise with Bayesian shrinkage and audits roster complement via 6 objective functional archetypes.</a:t>
-            </a:r>
-          </a:p>
-        </p:txBody>
-      </p:sp>
-      <p:sp>
-        <p:nvSpPr>
-          <p:cNvPr id="8" name="Rounded Rectangle 7"/>
+              <a:t>"WHO FITS"</a:t>
+            </a:r>
+          </a:p>
+          <a:p>
+            <a:pPr>
+              <a:defRPr sz="1050">
+                <a:solidFill>
+                  <a:srgbClr val="475569"/>
+                </a:solidFill>
+              </a:defRPr>
+            </a:pPr>
+            <a:r>
+              <a:t>• 6 objective functional archetypes</a:t>
+            </a:r>
+          </a:p>
+          <a:p>
+            <a:pPr>
+              <a:defRPr sz="1050">
+                <a:solidFill>
+                  <a:srgbClr val="475569"/>
+                </a:solidFill>
+              </a:defRPr>
+            </a:pPr>
+            <a:r>
+              <a:t>• Small-sample shooting shrinkage</a:t>
+            </a:r>
+          </a:p>
+          <a:p>
+            <a:pPr>
+              <a:defRPr sz="1050">
+                <a:solidFill>
+                  <a:srgbClr val="475569"/>
+                </a:solidFill>
+              </a:defRPr>
+            </a:pPr>
+            <a:r>
+              <a:t>• Roster complement &amp; role audit</a:t>
+            </a:r>
+          </a:p>
+        </p:txBody>
+      </p:sp>
+      <p:sp>
+        <p:nvSpPr>
+          <p:cNvPr id="9" name="Rounded Rectangle 8"/>
           <p:cNvSpPr/>
           <p:nvPr/>
         </p:nvSpPr>
         <p:spPr>
           <a:xfrm>
-            <a:off x="7863840" y="1737360"/>
-            <a:ext cx="3383280" cy="4114800"/>
+            <a:off x="7863840" y="2286000"/>
+            <a:ext cx="3383280" cy="2743200"/>
           </a:xfrm>
           <a:prstGeom prst="roundRect">
             <a:avLst/>
@@ -10804,37 +11524,127 @@
           </a:fontRef>
         </p:style>
         <p:txBody>
-          <a:bodyPr rtlCol="0" anchor="ctr" wrap="square" lIns="274320" rIns="274320" tIns="365760"/>
+          <a:bodyPr rtlCol="0" anchor="ctr" lIns="228600" rIns="228600" tIns="228600"/>
           <a:lstStyle/>
           <a:p>
             <a:pPr algn="ctr">
-              <a:defRPr sz="1600" b="1">
+              <a:defRPr sz="1300" b="1">
                 <a:solidFill>
                   <a:srgbClr val="16A34A"/>
                 </a:solidFill>
               </a:defRPr>
             </a:pPr>
             <a:r>
-              <a:t>Analytics Lead &amp; CTO</a:t>
-            </a:r>
-          </a:p>
-          <a:p>
-            <a:pPr>
-              <a:defRPr sz="1200">
+              <a:t>SPORTING DIRECTOR / GM</a:t>
+            </a:r>
+          </a:p>
+          <a:p>
+            <a:pPr>
+              <a:defRPr sz="1100" b="1">
                 <a:solidFill>
                   <a:srgbClr val="0F172A"/>
                 </a:solidFill>
               </a:defRPr>
             </a:pPr>
             <a:r>
-              <a:t>Provides a zero-cloud-cost, 227-test verified OLAP foundation in DuckDB and Parquet, ready for domestic league integration.</a:t>
-            </a:r>
-          </a:p>
-        </p:txBody>
-      </p:sp>
-      <p:sp>
-        <p:nvSpPr>
-          <p:cNvPr id="9" name="TextBox 8"/>
+              <a:t>"WHAT TO INVEST IN"</a:t>
+            </a:r>
+          </a:p>
+          <a:p>
+            <a:pPr>
+              <a:defRPr sz="1050">
+                <a:solidFill>
+                  <a:srgbClr val="475569"/>
+                </a:solidFill>
+              </a:defRPr>
+            </a:pPr>
+            <a:r>
+              <a:t>• Evidence-based contract valuation</a:t>
+            </a:r>
+          </a:p>
+          <a:p>
+            <a:pPr>
+              <a:defRPr sz="1050">
+                <a:solidFill>
+                  <a:srgbClr val="475569"/>
+                </a:solidFill>
+              </a:defRPr>
+            </a:pPr>
+            <a:r>
+              <a:t>• Career trajectory stability curves</a:t>
+            </a:r>
+          </a:p>
+          <a:p>
+            <a:pPr>
+              <a:defRPr sz="1050">
+                <a:solidFill>
+                  <a:srgbClr val="475569"/>
+                </a:solidFill>
+              </a:defRPr>
+            </a:pPr>
+            <a:r>
+              <a:t>• Recruitment risk minimization</a:t>
+            </a:r>
+          </a:p>
+        </p:txBody>
+      </p:sp>
+      <p:sp>
+        <p:nvSpPr>
+          <p:cNvPr id="10" name="Rounded Rectangle 9"/>
+          <p:cNvSpPr/>
+          <p:nvPr/>
+        </p:nvSpPr>
+        <p:spPr>
+          <a:xfrm>
+            <a:off x="731520" y="5166360"/>
+            <a:ext cx="10698480" cy="685800"/>
+          </a:xfrm>
+          <a:prstGeom prst="roundRect">
+            <a:avLst/>
+          </a:prstGeom>
+          <a:solidFill>
+            <a:srgbClr val="121E42"/>
+          </a:solidFill>
+          <a:ln>
+            <a:solidFill>
+              <a:srgbClr val="16A34A"/>
+            </a:solidFill>
+          </a:ln>
+        </p:spPr>
+        <p:style>
+          <a:lnRef idx="1">
+            <a:schemeClr val="accent1"/>
+          </a:lnRef>
+          <a:fillRef idx="3">
+            <a:schemeClr val="accent1"/>
+          </a:fillRef>
+          <a:effectRef idx="2">
+            <a:schemeClr val="accent1"/>
+          </a:effectRef>
+          <a:fontRef idx="minor">
+            <a:schemeClr val="lt1"/>
+          </a:fontRef>
+        </p:style>
+        <p:txBody>
+          <a:bodyPr rtlCol="0" anchor="ctr" lIns="274320"/>
+          <a:lstStyle/>
+          <a:p>
+            <a:pPr algn="ctr">
+              <a:defRPr sz="1100" b="1">
+                <a:solidFill>
+                  <a:srgbClr val="F8FAFC"/>
+                </a:solidFill>
+              </a:defRPr>
+            </a:pPr>
+            <a:r>
+              <a:t>VALUE PIPELINE:  RAW DATA (DuckDB Lakehouse)  -&gt;  EVIDENCE (R &amp; Calibrated ML)  -&gt;  DECISION SUPPORT (Pizarra &amp; Roster)</a:t>
+            </a:r>
+          </a:p>
+        </p:txBody>
+      </p:sp>
+      <p:sp>
+        <p:nvSpPr>
+          <p:cNvPr id="11" name="TextBox 10"/>
           <p:cNvSpPr txBox="1"/>
           <p:nvPr/>
         </p:nvSpPr>
@@ -10862,7 +11672,7 @@
               </a:defRPr>
             </a:pPr>
             <a:r>
-              <a:t>Design Focus: Built for immediate operational adoption in professional basketball environments.</a:t>
+              <a:t>Operational Impact: Moving from raw data tables directly to court and roster decisions.</a:t>
             </a:r>
           </a:p>
         </p:txBody>
@@ -10993,7 +11803,7 @@
               </a:defRPr>
             </a:pPr>
             <a:r>
-              <a:t>Day-1 Club Onboarding Roadmap</a:t>
+              <a:t>Day-1 Club Onboarding Roadmap (30 Days)</a:t>
             </a:r>
           </a:p>
         </p:txBody>
@@ -11028,7 +11838,7 @@
               </a:defRPr>
             </a:pPr>
             <a:r>
-              <a:t>How this system adapts to domestic club leagues (ACB, EuroLeague, BBL, NBA).</a:t>
+              <a:t>How this modular platform deploys seamlessly in domestic club leagues.</a:t>
             </a:r>
           </a:p>
         </p:txBody>
@@ -11041,8 +11851,62 @@
         </p:nvSpPr>
         <p:spPr>
           <a:xfrm>
-            <a:off x="731520" y="1737360"/>
-            <a:ext cx="3383280" cy="4114800"/>
+            <a:off x="731520" y="1645920"/>
+            <a:ext cx="10698480" cy="502920"/>
+          </a:xfrm>
+          <a:prstGeom prst="roundRect">
+            <a:avLst/>
+          </a:prstGeom>
+          <a:solidFill>
+            <a:srgbClr val="121E42"/>
+          </a:solidFill>
+          <a:ln>
+            <a:solidFill>
+              <a:srgbClr val="0284C7"/>
+            </a:solidFill>
+          </a:ln>
+        </p:spPr>
+        <p:style>
+          <a:lnRef idx="1">
+            <a:schemeClr val="accent1"/>
+          </a:lnRef>
+          <a:fillRef idx="3">
+            <a:schemeClr val="accent1"/>
+          </a:fillRef>
+          <a:effectRef idx="2">
+            <a:schemeClr val="accent1"/>
+          </a:effectRef>
+          <a:fontRef idx="minor">
+            <a:schemeClr val="lt1"/>
+          </a:fontRef>
+        </p:style>
+        <p:txBody>
+          <a:bodyPr rtlCol="0" anchor="ctr" lIns="274320"/>
+          <a:lstStyle/>
+          <a:p>
+            <a:pPr algn="ctr">
+              <a:defRPr sz="1200" b="1">
+                <a:solidFill>
+                  <a:srgbClr val="0284C7"/>
+                </a:solidFill>
+              </a:defRPr>
+            </a:pPr>
+            <a:r>
+              <a:t>TRANSITION TIMELINE:  DAY 01 --------------&gt; DAY 10 --------------&gt; DAY 20 --------------&gt; DAY 30</a:t>
+            </a:r>
+          </a:p>
+        </p:txBody>
+      </p:sp>
+      <p:sp>
+        <p:nvSpPr>
+          <p:cNvPr id="7" name="Rounded Rectangle 6"/>
+          <p:cNvSpPr/>
+          <p:nvPr/>
+        </p:nvSpPr>
+        <p:spPr>
+          <a:xfrm>
+            <a:off x="731520" y="2286000"/>
+            <a:ext cx="3383280" cy="2743200"/>
           </a:xfrm>
           <a:prstGeom prst="roundRect">
             <a:avLst/>
@@ -11071,44 +11935,80 @@
           </a:fontRef>
         </p:style>
         <p:txBody>
-          <a:bodyPr rtlCol="0" anchor="ctr" wrap="square" lIns="274320" rIns="274320" tIns="365760"/>
+          <a:bodyPr rtlCol="0" anchor="ctr" lIns="228600" rIns="228600" tIns="228600"/>
           <a:lstStyle/>
           <a:p>
             <a:pPr algn="ctr">
-              <a:defRPr sz="1600" b="1">
+              <a:defRPr sz="1300" b="1">
                 <a:solidFill>
                   <a:srgbClr val="0284C7"/>
                 </a:solidFill>
               </a:defRPr>
             </a:pPr>
             <a:r>
-              <a:t>Days 1–10: Data Ingestion</a:t>
-            </a:r>
-          </a:p>
-          <a:p>
-            <a:pPr>
-              <a:defRPr sz="1200">
+              <a:t>PHASE 01 : DATA AUDIT</a:t>
+            </a:r>
+          </a:p>
+          <a:p>
+            <a:pPr>
+              <a:defRPr sz="1100" b="1">
                 <a:solidFill>
                   <a:srgbClr val="0F172A"/>
                 </a:solidFill>
               </a:defRPr>
             </a:pPr>
             <a:r>
-              <a:t>Connect domestic league boxscores (Genius Sports, Synergy, EuroLeague API) into the DuckDB raw staging layer.</a:t>
-            </a:r>
-          </a:p>
-        </p:txBody>
-      </p:sp>
-      <p:sp>
-        <p:nvSpPr>
-          <p:cNvPr id="7" name="Rounded Rectangle 6"/>
+              <a:t>Days 1-10</a:t>
+            </a:r>
+          </a:p>
+          <a:p>
+            <a:pPr>
+              <a:defRPr sz="1050">
+                <a:solidFill>
+                  <a:srgbClr val="475569"/>
+                </a:solidFill>
+              </a:defRPr>
+            </a:pPr>
+            <a:r>
+              <a:t>• Connect domestic boxscores (Synergy, Genius, EuroLeague API)</a:t>
+            </a:r>
+          </a:p>
+          <a:p>
+            <a:pPr>
+              <a:defRPr sz="1050">
+                <a:solidFill>
+                  <a:srgbClr val="475569"/>
+                </a:solidFill>
+              </a:defRPr>
+            </a:pPr>
+            <a:r>
+              <a:t>• Validate relational DuckDB schema &amp; table contracts</a:t>
+            </a:r>
+          </a:p>
+          <a:p>
+            <a:pPr>
+              <a:defRPr sz="1050">
+                <a:solidFill>
+                  <a:srgbClr val="475569"/>
+                </a:solidFill>
+              </a:defRPr>
+            </a:pPr>
+            <a:r>
+              <a:t>• Execute automated QA suite (200 min/game invariants)</a:t>
+            </a:r>
+          </a:p>
+        </p:txBody>
+      </p:sp>
+      <p:sp>
+        <p:nvSpPr>
+          <p:cNvPr id="8" name="Rounded Rectangle 7"/>
           <p:cNvSpPr/>
           <p:nvPr/>
         </p:nvSpPr>
         <p:spPr>
           <a:xfrm>
-            <a:off x="4297680" y="1737360"/>
-            <a:ext cx="3383280" cy="4114800"/>
+            <a:off x="4297680" y="2286000"/>
+            <a:ext cx="3383280" cy="2743200"/>
           </a:xfrm>
           <a:prstGeom prst="roundRect">
             <a:avLst/>
@@ -11137,44 +12037,80 @@
           </a:fontRef>
         </p:style>
         <p:txBody>
-          <a:bodyPr rtlCol="0" anchor="ctr" wrap="square" lIns="274320" rIns="274320" tIns="365760"/>
+          <a:bodyPr rtlCol="0" anchor="ctr" lIns="228600" rIns="228600" tIns="228600"/>
           <a:lstStyle/>
           <a:p>
             <a:pPr algn="ctr">
-              <a:defRPr sz="1600" b="1">
+              <a:defRPr sz="1300" b="1">
                 <a:solidFill>
                   <a:srgbClr val="EA580C"/>
                 </a:solidFill>
               </a:defRPr>
             </a:pPr>
             <a:r>
-              <a:t>Days 11–20: Metric Customization</a:t>
-            </a:r>
-          </a:p>
-          <a:p>
-            <a:pPr>
-              <a:defRPr sz="1200">
+              <a:t>PHASE 02 : ANALYST WORKFLOW</a:t>
+            </a:r>
+          </a:p>
+          <a:p>
+            <a:pPr>
+              <a:defRPr sz="1100" b="1">
                 <a:solidFill>
                   <a:srgbClr val="0F172A"/>
                 </a:solidFill>
               </a:defRPr>
             </a:pPr>
             <a:r>
-              <a:t>Calibrate Four Factors baselines and Bayesian priors for the domestic league's specific pace and refereeing trends.</a:t>
-            </a:r>
-          </a:p>
-        </p:txBody>
-      </p:sp>
-      <p:sp>
-        <p:nvSpPr>
-          <p:cNvPr id="8" name="Rounded Rectangle 7"/>
+              <a:t>Days 11-20</a:t>
+            </a:r>
+          </a:p>
+          <a:p>
+            <a:pPr>
+              <a:defRPr sz="1050">
+                <a:solidFill>
+                  <a:srgbClr val="475569"/>
+                </a:solidFill>
+              </a:defRPr>
+            </a:pPr>
+            <a:r>
+              <a:t>• Calibrate league-specific Four Factors baselines</a:t>
+            </a:r>
+          </a:p>
+          <a:p>
+            <a:pPr>
+              <a:defRPr sz="1050">
+                <a:solidFill>
+                  <a:srgbClr val="475569"/>
+                </a:solidFill>
+              </a:defRPr>
+            </a:pPr>
+            <a:r>
+              <a:t>• Set Bayesian shrinkage priors (lambda = 0.75) for roster</a:t>
+            </a:r>
+          </a:p>
+          <a:p>
+            <a:pPr>
+              <a:defRPr sz="1050">
+                <a:solidFill>
+                  <a:srgbClr val="475569"/>
+                </a:solidFill>
+              </a:defRPr>
+            </a:pPr>
+            <a:r>
+              <a:t>• Train video analysts on anti-hindsight workspace</a:t>
+            </a:r>
+          </a:p>
+        </p:txBody>
+      </p:sp>
+      <p:sp>
+        <p:nvSpPr>
+          <p:cNvPr id="9" name="Rounded Rectangle 8"/>
           <p:cNvSpPr/>
           <p:nvPr/>
         </p:nvSpPr>
         <p:spPr>
           <a:xfrm>
-            <a:off x="7863840" y="1737360"/>
-            <a:ext cx="3383280" cy="4114800"/>
+            <a:off x="7863840" y="2286000"/>
+            <a:ext cx="3383280" cy="2743200"/>
           </a:xfrm>
           <a:prstGeom prst="roundRect">
             <a:avLst/>
@@ -11203,37 +12139,127 @@
           </a:fontRef>
         </p:style>
         <p:txBody>
-          <a:bodyPr rtlCol="0" anchor="ctr" wrap="square" lIns="274320" rIns="274320" tIns="365760"/>
+          <a:bodyPr rtlCol="0" anchor="ctr" lIns="228600" rIns="228600" tIns="228600"/>
           <a:lstStyle/>
           <a:p>
             <a:pPr algn="ctr">
-              <a:defRPr sz="1600" b="1">
+              <a:defRPr sz="1300" b="1">
                 <a:solidFill>
                   <a:srgbClr val="16A34A"/>
                 </a:solidFill>
               </a:defRPr>
             </a:pPr>
             <a:r>
-              <a:t>Days 21–30: Staff Integration</a:t>
-            </a:r>
-          </a:p>
-          <a:p>
-            <a:pPr>
-              <a:defRPr sz="1200">
+              <a:t>PHASE 03 : STAFF INTEGRATION</a:t>
+            </a:r>
+          </a:p>
+          <a:p>
+            <a:pPr>
+              <a:defRPr sz="1100" b="1">
                 <a:solidFill>
                   <a:srgbClr val="0F172A"/>
                 </a:solidFill>
               </a:defRPr>
             </a:pPr>
             <a:r>
-              <a:t>Deliver automated weekly pre-game briefs directly to coaching staff and train video coordinators on inconsistency alerts.</a:t>
-            </a:r>
-          </a:p>
-        </p:txBody>
-      </p:sp>
-      <p:sp>
-        <p:nvSpPr>
-          <p:cNvPr id="9" name="TextBox 8"/>
+              <a:t>Days 21-30</a:t>
+            </a:r>
+          </a:p>
+          <a:p>
+            <a:pPr>
+              <a:defRPr sz="1050">
+                <a:solidFill>
+                  <a:srgbClr val="475569"/>
+                </a:solidFill>
+              </a:defRPr>
+            </a:pPr>
+            <a:r>
+              <a:t>• Deliver automated pre-game briefs directly to coaching staff</a:t>
+            </a:r>
+          </a:p>
+          <a:p>
+            <a:pPr>
+              <a:defRPr sz="1050">
+                <a:solidFill>
+                  <a:srgbClr val="475569"/>
+                </a:solidFill>
+              </a:defRPr>
+            </a:pPr>
+            <a:r>
+              <a:t>• Integrate Four Factors alerts into whiteboard pre-game talks</a:t>
+            </a:r>
+          </a:p>
+          <a:p>
+            <a:pPr>
+              <a:defRPr sz="1050">
+                <a:solidFill>
+                  <a:srgbClr val="475569"/>
+                </a:solidFill>
+              </a:defRPr>
+            </a:pPr>
+            <a:r>
+              <a:t>• Establish weekly post-game accuracy review loop</a:t>
+            </a:r>
+          </a:p>
+        </p:txBody>
+      </p:sp>
+      <p:sp>
+        <p:nvSpPr>
+          <p:cNvPr id="10" name="Rounded Rectangle 9"/>
+          <p:cNvSpPr/>
+          <p:nvPr/>
+        </p:nvSpPr>
+        <p:spPr>
+          <a:xfrm>
+            <a:off x="731520" y="5166360"/>
+            <a:ext cx="10698480" cy="685800"/>
+          </a:xfrm>
+          <a:prstGeom prst="roundRect">
+            <a:avLst/>
+          </a:prstGeom>
+          <a:solidFill>
+            <a:srgbClr val="121E42"/>
+          </a:solidFill>
+          <a:ln>
+            <a:solidFill>
+              <a:srgbClr val="16A34A"/>
+            </a:solidFill>
+          </a:ln>
+        </p:spPr>
+        <p:style>
+          <a:lnRef idx="1">
+            <a:schemeClr val="accent1"/>
+          </a:lnRef>
+          <a:fillRef idx="3">
+            <a:schemeClr val="accent1"/>
+          </a:fillRef>
+          <a:effectRef idx="2">
+            <a:schemeClr val="accent1"/>
+          </a:effectRef>
+          <a:fontRef idx="minor">
+            <a:schemeClr val="lt1"/>
+          </a:fontRef>
+        </p:style>
+        <p:txBody>
+          <a:bodyPr rtlCol="0" anchor="ctr" lIns="274320"/>
+          <a:lstStyle/>
+          <a:p>
+            <a:pPr algn="ctr">
+              <a:defRPr sz="1100" b="1">
+                <a:solidFill>
+                  <a:srgbClr val="16A34A"/>
+                </a:solidFill>
+              </a:defRPr>
+            </a:pPr>
+            <a:r>
+              <a:t>⭐  DAY 30 MILESTONE: FULLY EMBEDDED DECISION SYSTEM  (Zero Cloud Overhead, 100% Offline Reproducibility)</a:t>
+            </a:r>
+          </a:p>
+        </p:txBody>
+      </p:sp>
+      <p:sp>
+        <p:nvSpPr>
+          <p:cNvPr id="11" name="TextBox 10"/>
           <p:cNvSpPr txBox="1"/>
           <p:nvPr/>
         </p:nvSpPr>
@@ -11261,7 +12287,7 @@
               </a:defRPr>
             </a:pPr>
             <a:r>
-              <a:t>Ready to Deploy: Modular architecture designed for seamless data source substitution.</a:t>
+              <a:t>Turnkey Deployment: Modular pipeline ready for immediate adoption in professional clubs.</a:t>
             </a:r>
           </a:p>
         </p:txBody>
@@ -12808,7 +13834,7 @@
               </a:defRPr>
             </a:pPr>
             <a:r>
-              <a:t>Every game across 18 FIBA tournaments (2005–2024).</a:t>
+              <a:t>Every game across 18 FIBA tournaments (2005-2024).</a:t>
             </a:r>
           </a:p>
         </p:txBody>

</xml_diff>